<commit_message>
tensile testing data added
</commit_message>
<xml_diff>
--- a/Manufacturing_Inflatables/Manufacturing Procedure.pptx
+++ b/Manufacturing_Inflatables/Manufacturing Procedure.pptx
@@ -105,7 +105,41 @@
       </a:defRPr>
     </a:lvl9pPr>
   </p:defaultTextStyle>
+  <p:extLst>
+    <p:ext uri="{EFAFB233-063F-42B5-8137-9DF3F51BA10A}">
+      <p15:sldGuideLst xmlns:p15="http://schemas.microsoft.com/office/powerpoint/2012/main"/>
+    </p:ext>
+  </p:extLst>
 </p:presentation>
+</file>
+
+<file path=ppt/changesInfos/changesInfo1.xml><?xml version="1.0" encoding="utf-8"?>
+<pc:chgInfo xmlns:a="http://schemas.openxmlformats.org/drawingml/2006/main" xmlns:r="http://schemas.openxmlformats.org/officeDocument/2006/relationships" xmlns:ac="http://schemas.microsoft.com/office/drawing/2013/main/command" xmlns:pc="http://schemas.microsoft.com/office/powerpoint/2013/main/command">
+  <pc:docChgLst>
+    <pc:chgData name="Edward Mott" userId="98acc0cc-f1c6-4c8a-b547-7f564c5b914b" providerId="ADAL" clId="{AEC600A2-3B9D-49DA-A8D2-ED42A743221E}"/>
+    <pc:docChg chg="custSel modSld">
+      <pc:chgData name="Edward Mott" userId="98acc0cc-f1c6-4c8a-b547-7f564c5b914b" providerId="ADAL" clId="{AEC600A2-3B9D-49DA-A8D2-ED42A743221E}" dt="2026-05-13T11:34:41.184" v="79" actId="20577"/>
+      <pc:docMkLst>
+        <pc:docMk/>
+      </pc:docMkLst>
+      <pc:sldChg chg="modSp mod">
+        <pc:chgData name="Edward Mott" userId="98acc0cc-f1c6-4c8a-b547-7f564c5b914b" providerId="ADAL" clId="{AEC600A2-3B9D-49DA-A8D2-ED42A743221E}" dt="2026-05-13T11:34:41.184" v="79" actId="20577"/>
+        <pc:sldMkLst>
+          <pc:docMk/>
+          <pc:sldMk cId="737969739" sldId="256"/>
+        </pc:sldMkLst>
+        <pc:spChg chg="mod">
+          <ac:chgData name="Edward Mott" userId="98acc0cc-f1c6-4c8a-b547-7f564c5b914b" providerId="ADAL" clId="{AEC600A2-3B9D-49DA-A8D2-ED42A743221E}" dt="2026-05-13T11:34:41.184" v="79" actId="20577"/>
+          <ac:spMkLst>
+            <pc:docMk/>
+            <pc:sldMk cId="737969739" sldId="256"/>
+            <ac:spMk id="2" creationId="{8BD3E25A-E2F8-77CE-B7FD-03F8638E0D81}"/>
+          </ac:spMkLst>
+        </pc:spChg>
+      </pc:sldChg>
+    </pc:docChg>
+  </pc:docChgLst>
+</pc:chgInfo>
 </file>
 
 <file path=ppt/slideLayouts/slideLayout1.xml><?xml version="1.0" encoding="utf-8"?>
@@ -239,7 +273,7 @@
           <a:p>
             <a:fld id="{E051C8A3-0454-4E47-89B2-59EA763B6CA5}" type="datetimeFigureOut">
               <a:rPr lang="en-GB" smtClean="0"/>
-              <a:t>23/02/2026</a:t>
+              <a:t>13/05/2026</a:t>
             </a:fld>
             <a:endParaRPr lang="en-GB"/>
           </a:p>
@@ -409,7 +443,7 @@
           <a:p>
             <a:fld id="{E051C8A3-0454-4E47-89B2-59EA763B6CA5}" type="datetimeFigureOut">
               <a:rPr lang="en-GB" smtClean="0"/>
-              <a:t>23/02/2026</a:t>
+              <a:t>13/05/2026</a:t>
             </a:fld>
             <a:endParaRPr lang="en-GB"/>
           </a:p>
@@ -589,7 +623,7 @@
           <a:p>
             <a:fld id="{E051C8A3-0454-4E47-89B2-59EA763B6CA5}" type="datetimeFigureOut">
               <a:rPr lang="en-GB" smtClean="0"/>
-              <a:t>23/02/2026</a:t>
+              <a:t>13/05/2026</a:t>
             </a:fld>
             <a:endParaRPr lang="en-GB"/>
           </a:p>
@@ -759,7 +793,7 @@
           <a:p>
             <a:fld id="{E051C8A3-0454-4E47-89B2-59EA763B6CA5}" type="datetimeFigureOut">
               <a:rPr lang="en-GB" smtClean="0"/>
-              <a:t>23/02/2026</a:t>
+              <a:t>13/05/2026</a:t>
             </a:fld>
             <a:endParaRPr lang="en-GB"/>
           </a:p>
@@ -1005,7 +1039,7 @@
           <a:p>
             <a:fld id="{E051C8A3-0454-4E47-89B2-59EA763B6CA5}" type="datetimeFigureOut">
               <a:rPr lang="en-GB" smtClean="0"/>
-              <a:t>23/02/2026</a:t>
+              <a:t>13/05/2026</a:t>
             </a:fld>
             <a:endParaRPr lang="en-GB"/>
           </a:p>
@@ -1237,7 +1271,7 @@
           <a:p>
             <a:fld id="{E051C8A3-0454-4E47-89B2-59EA763B6CA5}" type="datetimeFigureOut">
               <a:rPr lang="en-GB" smtClean="0"/>
-              <a:t>23/02/2026</a:t>
+              <a:t>13/05/2026</a:t>
             </a:fld>
             <a:endParaRPr lang="en-GB"/>
           </a:p>
@@ -1604,7 +1638,7 @@
           <a:p>
             <a:fld id="{E051C8A3-0454-4E47-89B2-59EA763B6CA5}" type="datetimeFigureOut">
               <a:rPr lang="en-GB" smtClean="0"/>
-              <a:t>23/02/2026</a:t>
+              <a:t>13/05/2026</a:t>
             </a:fld>
             <a:endParaRPr lang="en-GB"/>
           </a:p>
@@ -1722,7 +1756,7 @@
           <a:p>
             <a:fld id="{E051C8A3-0454-4E47-89B2-59EA763B6CA5}" type="datetimeFigureOut">
               <a:rPr lang="en-GB" smtClean="0"/>
-              <a:t>23/02/2026</a:t>
+              <a:t>13/05/2026</a:t>
             </a:fld>
             <a:endParaRPr lang="en-GB"/>
           </a:p>
@@ -1817,7 +1851,7 @@
           <a:p>
             <a:fld id="{E051C8A3-0454-4E47-89B2-59EA763B6CA5}" type="datetimeFigureOut">
               <a:rPr lang="en-GB" smtClean="0"/>
-              <a:t>23/02/2026</a:t>
+              <a:t>13/05/2026</a:t>
             </a:fld>
             <a:endParaRPr lang="en-GB"/>
           </a:p>
@@ -2094,7 +2128,7 @@
           <a:p>
             <a:fld id="{E051C8A3-0454-4E47-89B2-59EA763B6CA5}" type="datetimeFigureOut">
               <a:rPr lang="en-GB" smtClean="0"/>
-              <a:t>23/02/2026</a:t>
+              <a:t>13/05/2026</a:t>
             </a:fld>
             <a:endParaRPr lang="en-GB"/>
           </a:p>
@@ -2351,7 +2385,7 @@
           <a:p>
             <a:fld id="{E051C8A3-0454-4E47-89B2-59EA763B6CA5}" type="datetimeFigureOut">
               <a:rPr lang="en-GB" smtClean="0"/>
-              <a:t>23/02/2026</a:t>
+              <a:t>13/05/2026</a:t>
             </a:fld>
             <a:endParaRPr lang="en-GB"/>
           </a:p>
@@ -2564,7 +2598,7 @@
           <a:p>
             <a:fld id="{E051C8A3-0454-4E47-89B2-59EA763B6CA5}" type="datetimeFigureOut">
               <a:rPr lang="en-GB" smtClean="0"/>
-              <a:t>23/02/2026</a:t>
+              <a:t>13/05/2026</a:t>
             </a:fld>
             <a:endParaRPr lang="en-GB"/>
           </a:p>
@@ -2997,7 +3031,7 @@
           <a:p>
             <a:r>
               <a:rPr lang="en-GB" dirty="0"/>
-              <a:t>Crush Operating Instructions</a:t>
+              <a:t>Laser welding</a:t>
             </a:r>
           </a:p>
         </p:txBody>
@@ -3453,4 +3487,10 @@
     </a:ext>
   </a:extLst>
 </a:theme>
+</file>
+
+<file path=docMetadata/LabelInfo.xml><?xml version="1.0" encoding="utf-8"?>
+<clbl:labelList xmlns:clbl="http://schemas.microsoft.com/office/2020/mipLabelMetadata">
+  <clbl:label id="{1faf88fe-a998-4c5b-93c9-210a11d9a5c2}" enabled="0" method="" siteId="{1faf88fe-a998-4c5b-93c9-210a11d9a5c2}" removed="1"/>
+</clbl:labelList>
 </file>
</xml_diff>